<commit_message>
M16: regenerate meridian-actuarial under the wave's knobs (baseline + mail demonstrator)
Wholesale regen through the live airlock (claude-opus-4-8[1m], xhigh).
Baseline realism (business_calendar: 0 weekend meetings, book_is_sample,
style_specs: 12 specs, voice_diversify) plus real mail threads (eml 3->22
above 6 engagements; 4 mundane internal emails with exempt_author_mentions;
1 distribution list). Both hard-case knobs (signature-page fee, filename
date) retained. Validates clean (29 rules, EML/DL run, 0 errors); self-scores
100%; byte-pin re-derives; org-tier green.
</commit_message>
<xml_diff>
--- a/companies/meridian-actuarial/Engagements/Howard and Sons/2016.05.21 - Briefing Deck - Howard and Sons.pptx
+++ b/companies/meridian-actuarial/Engagements/Howard and Sons/2016.05.21 - Briefing Deck - Howard and Sons.pptx
@@ -3114,7 +3114,7 @@
                   <a:srgbClr val="4A2E2A"/>
                 </a:solidFill>
               </a:rPr>
-              <a:t>Pension Valuation: Howard and Sons</a:t>
+              <a:t>Pension Valuation for Howard and Sons</a:t>
             </a:r>
           </a:p>
         </p:txBody>
@@ -3141,25 +3141,25 @@
           <a:p>
             <a:pPr lvl="1"/>
             <a:r>
-              <a:t>Funding valuation of the Howard and Sons defined benefit plan</a:t>
+              <a:t>Engagement start: April 17, 2016</a:t>
             </a:r>
           </a:p>
           <a:p>
             <a:pPr lvl="1"/>
             <a:r>
-              <a:t>Prepared for the Director of Operations and the plan's trustees</a:t>
+              <a:t>Prepared by Jennifer Vasquez, Consulting Actuary</a:t>
             </a:r>
           </a:p>
           <a:p>
             <a:pPr lvl="1"/>
             <a:r>
-              <a:t>Engagement commenced April 17, 2016</a:t>
+              <a:t>Purpose: measure the plan's funded position and the contribution for the year ahead</a:t>
             </a:r>
           </a:p>
           <a:p>
             <a:pPr lvl="1"/>
             <a:r>
-              <a:t>Presented by Jennifer Vasquez, Consulting Actuary</a:t>
+              <a:t>For the Howard and Sons board and staff</a:t>
             </a:r>
           </a:p>
         </p:txBody>
@@ -3203,7 +3203,7 @@
                   <a:srgbClr val="4A2E2A"/>
                 </a:solidFill>
               </a:rPr>
-              <a:t>What We Were Asked To Do</a:t>
+              <a:t>What the valuation covers</a:t>
             </a:r>
           </a:p>
         </p:txBody>
@@ -3225,31 +3225,31 @@
           <a:p>
             <a:pPr lvl="1"/>
             <a:r>
-              <a:t>Measure plan liabilities on the funding basis at the valuation date</a:t>
+              <a:t>We measure the actuarial accrued liability and the normal cost under the plan's funding method.</a:t>
             </a:r>
           </a:p>
           <a:p>
             <a:pPr lvl="1"/>
             <a:r>
-              <a:t>Compare liabilities against trust assets and develop the recommended contribution</a:t>
+              <a:t>We report the funded ratio and a recommended contribution for the coming year.</a:t>
             </a:r>
           </a:p>
           <a:p>
             <a:pPr lvl="1"/>
             <a:r>
-              <a:t>Explain the movement in funded position since the prior valuation</a:t>
+              <a:t>We reconcile this year's results to the prior valuation, so any change is explained and not just stated.</a:t>
             </a:r>
           </a:p>
           <a:p>
             <a:pPr lvl="1"/>
             <a:r>
-              <a:t>Deliver the exhibit workbook and the auditor disclosure schedules</a:t>
+              <a:t>We document every assumption and every data source that stands behind the numbers.</a:t>
             </a:r>
           </a:p>
           <a:p>
             <a:pPr lvl="1"/>
             <a:r>
-              <a:t>Work performed under the Actuarial Standards of Practice; opinion signed by Robert Lawrence</a:t>
+              <a:t>Where the data cannot answer a question, we say so rather than estimate around it.</a:t>
             </a:r>
           </a:p>
         </p:txBody>
@@ -3293,7 +3293,7 @@
                   <a:srgbClr val="4A2E2A"/>
                 </a:solidFill>
               </a:rPr>
-              <a:t>Where the Work Stands</a:t>
+              <a:t>How the work is staffed</a:t>
             </a:r>
           </a:p>
         </p:txBody>
@@ -3315,31 +3315,31 @@
           <a:p>
             <a:pPr lvl="1"/>
             <a:r>
-              <a:t>Census extract received and reconciled to the prior population by David Sherman</a:t>
+              <a:t>David Sherman reconciles the census and documents the data we rely on.</a:t>
             </a:r>
           </a:p>
           <a:p>
             <a:pPr lvl="1"/>
             <a:r>
-              <a:t>Plan provisions summary drafted from the plan document and amendments by Jeffrey Ochoa</a:t>
+              <a:t>Jeffrey Ochoa builds the valuation model and ties each result back to the assumption that drives it.</a:t>
             </a:r>
           </a:p>
           <a:p>
             <a:pPr lvl="1"/>
             <a:r>
-              <a:t>Two data items still open: beneficiary dates of birth on a subset of inactives, and one amendment</a:t>
+              <a:t>Jennifer Vasquez signs the opinion and owns the judgment calls.</a:t>
             </a:r>
           </a:p>
           <a:p>
             <a:pPr lvl="1"/>
             <a:r>
-              <a:t>Assumption review underway; nothing recommended yet</a:t>
+              <a:t>Elizabeth Horne is our point of contact for data and plan questions.</a:t>
             </a:r>
           </a:p>
           <a:p>
             <a:pPr lvl="1"/>
             <a:r>
-              <a:t>Valuation runs begin once the open items close</a:t>
+              <a:t>We confirm decisions in writing, so no one is working from an old version.</a:t>
             </a:r>
           </a:p>
         </p:txBody>
@@ -3383,7 +3383,7 @@
                   <a:srgbClr val="4A2E2A"/>
                 </a:solidFill>
               </a:rPr>
-              <a:t>Data and What We Rely On</a:t>
+              <a:t>What you will receive</a:t>
             </a:r>
           </a:p>
         </p:txBody>
@@ -3405,25 +3405,25 @@
           <a:p>
             <a:pPr lvl="1"/>
             <a:r>
-              <a:t>We rely on the census, the trust statements, and the plan document as furnished by Elizabeth Horne and her staff</a:t>
+              <a:t>A workbook of exhibits: the liabilities, the assets, and the resulting funded position.</a:t>
             </a:r>
           </a:p>
           <a:p>
             <a:pPr lvl="1"/>
             <a:r>
-              <a:t>We review for consistency and reconcile against the prior valuation; we do not audit</a:t>
+              <a:t>A report that interprets the exhibits and states our opinion plainly.</a:t>
             </a:r>
           </a:p>
           <a:p>
             <a:pPr lvl="1"/>
             <a:r>
-              <a:t>Where an item is unavailable we assume, and we disclose both the assumption and the fact of it</a:t>
+              <a:t>A short summary the board can read without the detail behind it.</a:t>
             </a:r>
           </a:p>
           <a:p>
             <a:pPr lvl="1"/>
             <a:r>
-              <a:t>Data quality drives the schedule more than anything else on our side</a:t>
+              <a:t>The full set of assumptions and data sources, laid out for review.</a:t>
             </a:r>
           </a:p>
         </p:txBody>
@@ -3467,7 +3467,7 @@
                   <a:srgbClr val="4A2E2A"/>
                 </a:solidFill>
               </a:rPr>
-              <a:t>Assumptions: Measurement Is Not Judgment</a:t>
+              <a:t>Where we are now</a:t>
             </a:r>
           </a:p>
         </p:txBody>
@@ -3489,31 +3489,25 @@
           <a:p>
             <a:pPr lvl="1"/>
             <a:r>
-              <a:t>Measurement is what the data show; judgment is what we assume about the future</a:t>
+              <a:t>The participant census is in and being reconciled to last year's file.</a:t>
             </a:r>
           </a:p>
           <a:p>
             <a:pPr lvl="1"/>
             <a:r>
-              <a:t>Mortality is the live question this cycle and we expect it to move the liability</a:t>
+              <a:t>The year-end asset statement and one plan-provision question are still open with your team.</a:t>
             </a:r>
           </a:p>
           <a:p>
             <a:pPr lvl="1"/>
             <a:r>
-              <a:t>We will show the effect of any assumption change separately, so you can see it</a:t>
+              <a:t>The assumptions are carried from the last study and will be reviewed before any results.</a:t>
             </a:r>
           </a:p>
           <a:p>
             <a:pPr lvl="1"/>
             <a:r>
-              <a:t>We recommend; the board adopts</a:t>
-            </a:r>
-          </a:p>
-          <a:p>
-            <a:pPr lvl="1"/>
-            <a:r>
-              <a:t>No number leaves this engagement before it is reviewed and signed</a:t>
+              <a:t>No results yet; the work at this point is settling the inputs.</a:t>
             </a:r>
           </a:p>
         </p:txBody>
@@ -3557,7 +3551,7 @@
                   <a:srgbClr val="4A2E2A"/>
                 </a:solidFill>
               </a:rPr>
-              <a:t>Next Steps</a:t>
+              <a:t>Next steps</a:t>
             </a:r>
           </a:p>
         </p:txBody>
@@ -3579,31 +3573,25 @@
           <a:p>
             <a:pPr lvl="1"/>
             <a:r>
-              <a:t>Close the two open data items with your recordkeeper</a:t>
+              <a:t>Send the year-end asset statement.</a:t>
             </a:r>
           </a:p>
           <a:p>
             <a:pPr lvl="1"/>
             <a:r>
-              <a:t>Complete the provisions check and the assumption review</a:t>
+              <a:t>Confirm the disability provision, so the valuation matches the plan document.</a:t>
             </a:r>
           </a:p>
           <a:p>
             <a:pPr lvl="1"/>
             <a:r>
-              <a:t>Run the valuation and build the exhibits</a:t>
+              <a:t>We finish the census reconciliation and load the reviewed assumptions.</a:t>
             </a:r>
           </a:p>
           <a:p>
             <a:pPr lvl="1"/>
             <a:r>
-              <a:t>Draft results to Howard and Sons for review before anything goes to the board</a:t>
-            </a:r>
-          </a:p>
-          <a:p>
-            <a:pPr lvl="1"/>
-            <a:r>
-              <a:t>Questions to Jennifer Vasquez; data questions direct to David Sherman</a:t>
+              <a:t>We bring preliminary results back to you before anything is treated as final.</a:t>
             </a:r>
           </a:p>
         </p:txBody>

</xml_diff>